<commit_message>
docs: README, arquitectura, guion, entregables y deck con POE, generador, seguridad y cifras reproducibles
</commit_message>
<xml_diff>
--- a/pitch/QubitGuard_pitch.pptx
+++ b/pitch/QubitGuard_pitch.pptx
@@ -5149,7 +5149,7 @@
                 </a:solidFill>
                 <a:latin typeface="Calibri"/>
               </a:rPr>
-              <a:t>HTML/CSS/TypeScript</a:t>
+              <a:t>TypeScript sin frameworks</a:t>
             </a:r>
           </a:p>
           <a:p>
@@ -5165,7 +5165,7 @@
                 </a:solidFill>
                 <a:latin typeface="Calibri"/>
               </a:rPr>
-              <a:t>sin frameworks</a:t>
+              <a:t>ni dependencias de runtime</a:t>
             </a:r>
           </a:p>
           <a:p>
@@ -5181,7 +5181,7 @@
                 </a:solidFill>
                 <a:latin typeface="Calibri"/>
               </a:rPr>
-              <a:t>Analizador local</a:t>
+              <a:t>Contraseñas solo aquí</a:t>
             </a:r>
           </a:p>
         </p:txBody>
@@ -5347,7 +5347,7 @@
                 </a:solidFill>
                 <a:latin typeface="Calibri"/>
               </a:rPr>
-              <a:t>Endpoints de</a:t>
+              <a:t>Cabeceras y CSP, caché</a:t>
             </a:r>
           </a:p>
           <a:p>
@@ -5363,7 +5363,7 @@
                 </a:solidFill>
                 <a:latin typeface="Calibri"/>
               </a:rPr>
-              <a:t>experimentos y</a:t>
+              <a:t>gzip, límite de 2</a:t>
             </a:r>
           </a:p>
           <a:p>
@@ -5379,7 +5379,7 @@
                 </a:solidFill>
                 <a:latin typeface="Calibri"/>
               </a:rPr>
-              <a:t>reto diario</a:t>
+              <a:t>simulaciones ruidosas</a:t>
             </a:r>
           </a:p>
         </p:txBody>
@@ -5616,7 +5616,7 @@
                 </a:solidFill>
                 <a:latin typeface="Consolas"/>
               </a:rPr>
-              <a:t>Secciones: reto diario (racha, XP, niveles) | laboratorio Grover 2..6 qubits</a:t>
+              <a:t>Laboratorio Grover 2..6 qubits: Predice, Observa, Explica</a:t>
             </a:r>
           </a:p>
           <a:p>
@@ -5632,7 +5632,7 @@
                 </a:solidFill>
                 <a:latin typeface="Consolas"/>
               </a:rPr>
-              <a:t>histograma + curva sin² exacta + circuito | Monte Carlo vs Grover con tabla de speedup</a:t>
+              <a:t>histograma + curva sin² exacta + circuito + ruido FakeFez</a:t>
             </a:r>
           </a:p>
           <a:p>
@@ -5648,7 +5648,7 @@
                 </a:solidFill>
                 <a:latin typeface="Consolas"/>
               </a:rPr>
-              <a:t>criptografía poscuántica | limitaciones honestas</a:t>
+              <a:t>Tu ruta (5 pasos) | Reto diario | Azar frente a Grover | Tu contraseña</a:t>
             </a:r>
           </a:p>
           <a:p>
@@ -5664,7 +5664,7 @@
                 </a:solidFill>
                 <a:latin typeface="Consolas"/>
               </a:rPr>
-              <a:t>Calidad: tests pytest y CI en GitHub Actions</a:t>
+              <a:t>Calidad: 42 pruebas pytest, 23 de frontend, WCAG 2.2 AA</a:t>
             </a:r>
           </a:p>
         </p:txBody>
@@ -5997,7 +5997,7 @@
                 </a:solidFill>
                 <a:latin typeface="Calibri"/>
               </a:rPr>
-              <a:t>Privacidad y criptografía poscuántica</a:t>
+              <a:t>Seguridad, generador y poscuántica</a:t>
             </a:r>
           </a:p>
         </p:txBody>
@@ -6163,7 +6163,7 @@
                 </a:solidFill>
                 <a:latin typeface="Calibri"/>
               </a:rPr>
-              <a:t>Privacidad</a:t>
+              <a:t>Generador en el navegador</a:t>
             </a:r>
           </a:p>
         </p:txBody>
@@ -6202,7 +6202,7 @@
                 </a:solidFill>
                 <a:latin typeface="Calibri"/>
               </a:rPr>
-              <a:t>El analizador de contraseñas corre 100 % en el navegador.</a:t>
+              <a:t>crypto.getRandomValues, sin semilla: el código es público y aun así no se puede reproducir.</a:t>
             </a:r>
           </a:p>
           <a:p>
@@ -6218,7 +6218,7 @@
                 </a:solidFill>
                 <a:latin typeface="Calibri"/>
               </a:rPr>
-              <a:t>La contraseña nunca va al backend.</a:t>
+              <a:t>Caracteres, frase (2072 palabras) o mejorar la mía.</a:t>
             </a:r>
           </a:p>
           <a:p>
@@ -6234,7 +6234,23 @@
                 </a:solidFill>
                 <a:latin typeface="Calibri"/>
               </a:rPr>
-              <a:t>Un test de privacidad lo comprueba.</a:t>
+              <a:t>Meta resistente a Grover: 128 bits (64 efectivos).</a:t>
+            </a:r>
+          </a:p>
+          <a:p>
+            <a:pPr>
+              <a:spcAft>
+                <a:spcPts val="600"/>
+              </a:spcAft>
+            </a:pPr>
+            <a:r>
+              <a:rPr sz="1600" b="0">
+                <a:solidFill>
+                  <a:srgbClr val="E5E7EB"/>
+                </a:solidFill>
+                <a:latin typeface="Calibri"/>
+              </a:rPr>
+              <a:t>La contraseña nunca va al backend; un test lo comprueba.</a:t>
             </a:r>
           </a:p>
         </p:txBody>
@@ -6318,7 +6334,7 @@
                 </a:solidFill>
                 <a:latin typeface="Calibri"/>
               </a:rPr>
-              <a:t>Poscuántica</a:t>
+              <a:t>Seguridad y poscuántica</a:t>
             </a:r>
           </a:p>
         </p:txBody>
@@ -6357,7 +6373,7 @@
                 </a:solidFill>
                 <a:latin typeface="Calibri"/>
               </a:rPr>
-              <a:t>Grover vs AES: mejora cuadrática, se compensa con claves más largas.</a:t>
+              <a:t>CSP default-src 'self', solo archivos públicos, gzip y caché.</a:t>
             </a:r>
           </a:p>
           <a:p>
@@ -6373,7 +6389,7 @@
                 </a:solidFill>
                 <a:latin typeface="Calibri"/>
               </a:rPr>
-              <a:t>Shor vs RSA/ECC: ruptura, hay que migrar.</a:t>
+              <a:t>Máximo 2 simulaciones ruidosas a la vez (503 + Retry-After).</a:t>
             </a:r>
           </a:p>
           <a:p>
@@ -6389,7 +6405,7 @@
                 </a:solidFill>
                 <a:latin typeface="Calibri"/>
               </a:rPr>
-              <a:t>NIST FIPS 203 / 204 / 205.</a:t>
+              <a:t>Funciona sin internet; demo con Cloudflare Tunnel.</a:t>
             </a:r>
           </a:p>
           <a:p>
@@ -6405,7 +6421,7 @@
                 </a:solidFill>
                 <a:latin typeface="Calibri"/>
               </a:rPr>
-              <a:t>Harvest now, decrypt later.</a:t>
+              <a:t>Grover vs AES: claves más largas. Shor vs RSA/ECC: migrar a NIST FIPS 203 / 204 / 205.</a:t>
             </a:r>
           </a:p>
         </p:txBody>
@@ -6470,7 +6486,7 @@
                 </a:solidFill>
                 <a:latin typeface="Calibri"/>
               </a:rPr>
-              <a:t>Limitaciones y validación</a:t>
+              <a:t>Validación y limitaciones</a:t>
             </a:r>
           </a:p>
         </p:txBody>
@@ -6576,7 +6592,7 @@
           </a:solidFill>
           <a:ln w="19050">
             <a:solidFill>
-              <a:srgbClr val="E879F9"/>
+              <a:srgbClr val="22D3EE"/>
             </a:solidFill>
           </a:ln>
         </p:spPr>
@@ -6632,11 +6648,11 @@
             <a:r>
               <a:rPr sz="2000" b="1">
                 <a:solidFill>
-                  <a:srgbClr val="E879F9"/>
+                  <a:srgbClr val="22D3EE"/>
                 </a:solidFill>
                 <a:latin typeface="Calibri"/>
               </a:rPr>
-              <a:t>Limitaciones honestas</a:t>
+              <a:t>Medido (semilla fija)</a:t>
             </a:r>
           </a:p>
         </p:txBody>
@@ -6673,9 +6689,9 @@
                 <a:solidFill>
                   <a:srgbClr val="E5E7EB"/>
                 </a:solidFill>
-                <a:latin typeface="Calibri"/>
-              </a:rPr>
-              <a:t>Ruido simulado (FakeFez), no hardware real.</a:t>
+                <a:latin typeface="Consolas"/>
+              </a:rPr>
+              <a:t>Grover n=4, k=3, 2048 disparos:</a:t>
             </a:r>
           </a:p>
           <a:p>
@@ -6689,9 +6705,9 @@
                 <a:solidFill>
                   <a:srgbClr val="E5E7EB"/>
                 </a:solidFill>
-                <a:latin typeface="Calibri"/>
-              </a:rPr>
-              <a:t>Grover es mejora cuadrática; no rompe AES hoy.</a:t>
+                <a:latin typeface="Consolas"/>
+              </a:rPr>
+              <a:t>medido 0,954 vs teórico 0,961</a:t>
             </a:r>
           </a:p>
           <a:p>
@@ -6705,9 +6721,9 @@
                 <a:solidFill>
                   <a:srgbClr val="E5E7EB"/>
                 </a:solidFill>
-                <a:latin typeface="Calibri"/>
-              </a:rPr>
-              <a:t>Simulación hasta 6 qubits (crece exponencial).</a:t>
+                <a:latin typeface="Consolas"/>
+              </a:rPr>
+              <a:t>Curva Statevector vs fórmula: error 6e-14</a:t>
             </a:r>
           </a:p>
           <a:p>
@@ -6721,9 +6737,25 @@
                 <a:solidFill>
                   <a:srgbClr val="E5E7EB"/>
                 </a:solidFill>
-                <a:latin typeface="Calibri"/>
-              </a:rPr>
-              <a:t>El ruido baja la P real frente a la teoría.</a:t>
+                <a:latin typeface="Consolas"/>
+              </a:rPr>
+              <a:t>FakeFez n=6: éxito 0,031 ≈ azar (1/64)</a:t>
+            </a:r>
+          </a:p>
+          <a:p>
+            <a:pPr>
+              <a:spcAft>
+                <a:spcPts val="600"/>
+              </a:spcAft>
+            </a:pPr>
+            <a:r>
+              <a:rPr sz="1600" b="0">
+                <a:solidFill>
+                  <a:srgbClr val="E5E7EB"/>
+                </a:solidFill>
+                <a:latin typeface="Consolas"/>
+              </a:rPr>
+              <a:t>Monte Carlo 10 bits: media 513,3 vs 512,5</a:t>
             </a:r>
           </a:p>
         </p:txBody>
@@ -6747,7 +6779,7 @@
           </a:solidFill>
           <a:ln w="19050">
             <a:solidFill>
-              <a:srgbClr val="22D3EE"/>
+              <a:srgbClr val="E879F9"/>
             </a:solidFill>
           </a:ln>
         </p:spPr>
@@ -6803,11 +6835,11 @@
             <a:r>
               <a:rPr sz="2000" b="1">
                 <a:solidFill>
-                  <a:srgbClr val="22D3EE"/>
+                  <a:srgbClr val="E879F9"/>
                 </a:solidFill>
                 <a:latin typeface="Calibri"/>
               </a:rPr>
-              <a:t>Validación</a:t>
+              <a:t>Limitaciones honestas</a:t>
             </a:r>
           </a:p>
         </p:txBody>
@@ -6846,7 +6878,7 @@
                 </a:solidFill>
                 <a:latin typeface="Calibri"/>
               </a:rPr>
-              <a:t>Resultados medidos comparados con sin²((2k+1)θ) calculada con Statevector.</a:t>
+              <a:t>Ruido simulado (FakeFez), no hardware real.</a:t>
             </a:r>
           </a:p>
           <a:p>
@@ -6862,7 +6894,7 @@
                 </a:solidFill>
                 <a:latin typeface="Calibri"/>
               </a:rPr>
-              <a:t>Tests pytest y CI en GitHub Actions.</a:t>
+              <a:t>Grover es mejora cuadrática; no rompe AES hoy.</a:t>
             </a:r>
           </a:p>
           <a:p>
@@ -6878,7 +6910,39 @@
                 </a:solidFill>
                 <a:latin typeface="Calibri"/>
               </a:rPr>
-              <a:t>Piloto de retención en aula: pendiente.</a:t>
+              <a:t>Simulación hasta 6 qubits (crece exponencial).</a:t>
+            </a:r>
+          </a:p>
+          <a:p>
+            <a:pPr>
+              <a:spcAft>
+                <a:spcPts val="600"/>
+              </a:spcAft>
+            </a:pPr>
+            <a:r>
+              <a:rPr sz="1600" b="0">
+                <a:solidFill>
+                  <a:srgbClr val="E5E7EB"/>
+                </a:solidFill>
+                <a:latin typeface="Calibri"/>
+              </a:rPr>
+              <a:t>El ruido borra la amplificación.</a:t>
+            </a:r>
+          </a:p>
+          <a:p>
+            <a:pPr>
+              <a:spcAft>
+                <a:spcPts val="600"/>
+              </a:spcAft>
+            </a:pPr>
+            <a:r>
+              <a:rPr sz="1600" b="0">
+                <a:solidFill>
+                  <a:srgbClr val="E5E7EB"/>
+                </a:solidFill>
+                <a:latin typeface="Calibri"/>
+              </a:rPr>
+              <a:t>Retención en aula: sin medir todavía.</a:t>
             </a:r>
           </a:p>
         </p:txBody>
@@ -7355,7 +7419,7 @@
                 </a:solidFill>
                 <a:latin typeface="Consolas"/>
               </a:rPr>
-              <a:t>racha / XP</a:t>
+              <a:t>5 pasos</a:t>
             </a:r>
           </a:p>
         </p:txBody>
@@ -7394,7 +7458,7 @@
                 </a:solidFill>
                 <a:latin typeface="Calibri"/>
               </a:rPr>
-              <a:t>niveles</a:t>
+              <a:t>6 logros, racha, XP</a:t>
             </a:r>
           </a:p>
         </p:txBody>
@@ -7433,7 +7497,7 @@
                 </a:solidFill>
                 <a:latin typeface="Calibri"/>
               </a:rPr>
-              <a:t>Monte Carlo adivina. Grover amplifica.</a:t>
+              <a:t>Predice, Observa, Explica: te comprometes antes de mirar.</a:t>
             </a:r>
           </a:p>
           <a:p>
@@ -7449,7 +7513,7 @@
                 </a:solidFill>
                 <a:latin typeface="Calibri"/>
               </a:rPr>
-              <a:t>QubitGuard te deja sentir la diferencia en 3 minutos al día.</a:t>
+              <a:t>Monte Carlo adivina. Grover amplifica. 3 minutos al día.</a:t>
             </a:r>
           </a:p>
         </p:txBody>

</xml_diff>

<commit_message>
docs: README completo (problema, uso, librerías y funciones, arquitectura, hardware IBM, CasaOS, resultados, referencias) y pitch actualizado
</commit_message>
<xml_diff>
--- a/pitch/QubitGuard_pitch.pptx
+++ b/pitch/QubitGuard_pitch.pptx
@@ -549,6 +549,322 @@
     <c:plotVisOnly val="1"/>
     <c:dispBlanksAs val="gap"/>
     <c:showDLblsOverMax val="0"/>
+  </c:chart>
+  <c:txPr>
+    <a:bodyPr/>
+    <a:lstStyle/>
+    <a:p>
+      <a:pPr>
+        <a:defRPr sz="1800"/>
+      </a:pPr>
+      <a:endParaRPr lang="en-US"/>
+    </a:p>
+  </c:txPr>
+  <c:externalData r:id="rId1">
+    <c:autoUpdate val="0"/>
+  </c:externalData>
+</c:chartSpace>
+</file>
+
+<file path=ppt/charts/chart2.xml><?xml version="1.0" encoding="utf-8"?>
+<c:chartSpace xmlns:c="http://schemas.openxmlformats.org/drawingml/2006/chart" xmlns:a="http://schemas.openxmlformats.org/drawingml/2006/main" xmlns:r="http://schemas.openxmlformats.org/officeDocument/2006/relationships">
+  <c:date1904 val="0"/>
+  <c:chart>
+    <c:title>
+      <c:tx>
+        <c:rich>
+          <a:bodyPr/>
+          <a:lstStyle/>
+          <a:p>
+            <a:r>
+              <a:rPr sz="1400">
+                <a:solidFill>
+                  <a:srgbClr val="9CA3AF"/>
+                </a:solidFill>
+              </a:rPr>
+              <a:t>Probabilidad de acertar (simulación FakeFez, no QPU)</a:t>
+            </a:r>
+          </a:p>
+        </c:rich>
+      </c:tx>
+      <c:layout/>
+      <c:overlay val="0"/>
+    </c:title>
+    <c:autoTitleDeleted val="0"/>
+    <c:plotArea>
+      <c:barChart>
+        <c:barDir val="col"/>
+        <c:grouping val="clustered"/>
+        <c:ser>
+          <c:idx val="0"/>
+          <c:order val="0"/>
+          <c:tx>
+            <c:strRef>
+              <c:f>Sheet1!$B$1</c:f>
+              <c:strCache>
+                <c:ptCount val="1"/>
+                <c:pt idx="0">
+                  <c:v>Ideal (teoría)</c:v>
+                </c:pt>
+              </c:strCache>
+            </c:strRef>
+          </c:tx>
+          <c:spPr>
+            <a:solidFill>
+              <a:srgbClr val="22D3EE"/>
+            </a:solidFill>
+          </c:spPr>
+          <c:cat>
+            <c:strRef>
+              <c:f>Sheet1!$A$2:$A$5</c:f>
+              <c:strCache>
+                <c:ptCount val="4"/>
+                <c:pt idx="0">
+                  <c:v>n=3 (101)</c:v>
+                </c:pt>
+                <c:pt idx="1">
+                  <c:v>n=4 (1010)</c:v>
+                </c:pt>
+                <c:pt idx="2">
+                  <c:v>n=5 (10101)</c:v>
+                </c:pt>
+                <c:pt idx="3">
+                  <c:v>n=6 (101010)</c:v>
+                </c:pt>
+              </c:strCache>
+            </c:strRef>
+          </c:cat>
+          <c:val>
+            <c:numRef>
+              <c:f>Sheet1!$B$2:$B$5</c:f>
+              <c:numCache>
+                <c:formatCode>General</c:formatCode>
+                <c:ptCount val="4"/>
+                <c:pt idx="0">
+                  <c:v>0.945</c:v>
+                </c:pt>
+                <c:pt idx="1">
+                  <c:v>0.961</c:v>
+                </c:pt>
+                <c:pt idx="2">
+                  <c:v>0.999</c:v>
+                </c:pt>
+                <c:pt idx="3">
+                  <c:v>0.997</c:v>
+                </c:pt>
+              </c:numCache>
+            </c:numRef>
+          </c:val>
+        </c:ser>
+        <c:ser>
+          <c:idx val="1"/>
+          <c:order val="1"/>
+          <c:tx>
+            <c:strRef>
+              <c:f>Sheet1!$C$1</c:f>
+              <c:strCache>
+                <c:ptCount val="1"/>
+                <c:pt idx="0">
+                  <c:v>Medido en FakeFez</c:v>
+                </c:pt>
+              </c:strCache>
+            </c:strRef>
+          </c:tx>
+          <c:spPr>
+            <a:solidFill>
+              <a:srgbClr val="E879F9"/>
+            </a:solidFill>
+          </c:spPr>
+          <c:cat>
+            <c:strRef>
+              <c:f>Sheet1!$A$2:$A$5</c:f>
+              <c:strCache>
+                <c:ptCount val="4"/>
+                <c:pt idx="0">
+                  <c:v>n=3 (101)</c:v>
+                </c:pt>
+                <c:pt idx="1">
+                  <c:v>n=4 (1010)</c:v>
+                </c:pt>
+                <c:pt idx="2">
+                  <c:v>n=5 (10101)</c:v>
+                </c:pt>
+                <c:pt idx="3">
+                  <c:v>n=6 (101010)</c:v>
+                </c:pt>
+              </c:strCache>
+            </c:strRef>
+          </c:cat>
+          <c:val>
+            <c:numRef>
+              <c:f>Sheet1!$C$2:$C$5</c:f>
+              <c:numCache>
+                <c:formatCode>General</c:formatCode>
+                <c:ptCount val="4"/>
+                <c:pt idx="0">
+                  <c:v>0.802</c:v>
+                </c:pt>
+                <c:pt idx="1">
+                  <c:v>0.662</c:v>
+                </c:pt>
+                <c:pt idx="2">
+                  <c:v>0.184</c:v>
+                </c:pt>
+                <c:pt idx="3">
+                  <c:v>0.0166</c:v>
+                </c:pt>
+              </c:numCache>
+            </c:numRef>
+          </c:val>
+        </c:ser>
+        <c:ser>
+          <c:idx val="2"/>
+          <c:order val="2"/>
+          <c:tx>
+            <c:strRef>
+              <c:f>Sheet1!$D$1</c:f>
+              <c:strCache>
+                <c:ptCount val="1"/>
+                <c:pt idx="0">
+                  <c:v>Azar 1/N</c:v>
+                </c:pt>
+              </c:strCache>
+            </c:strRef>
+          </c:tx>
+          <c:spPr>
+            <a:solidFill>
+              <a:srgbClr val="9CA3AF"/>
+            </a:solidFill>
+          </c:spPr>
+          <c:cat>
+            <c:strRef>
+              <c:f>Sheet1!$A$2:$A$5</c:f>
+              <c:strCache>
+                <c:ptCount val="4"/>
+                <c:pt idx="0">
+                  <c:v>n=3 (101)</c:v>
+                </c:pt>
+                <c:pt idx="1">
+                  <c:v>n=4 (1010)</c:v>
+                </c:pt>
+                <c:pt idx="2">
+                  <c:v>n=5 (10101)</c:v>
+                </c:pt>
+                <c:pt idx="3">
+                  <c:v>n=6 (101010)</c:v>
+                </c:pt>
+              </c:strCache>
+            </c:strRef>
+          </c:cat>
+          <c:val>
+            <c:numRef>
+              <c:f>Sheet1!$D$2:$D$5</c:f>
+              <c:numCache>
+                <c:formatCode>General</c:formatCode>
+                <c:ptCount val="4"/>
+                <c:pt idx="0">
+                  <c:v>0.125</c:v>
+                </c:pt>
+                <c:pt idx="1">
+                  <c:v>0.0625</c:v>
+                </c:pt>
+                <c:pt idx="2">
+                  <c:v>0.031</c:v>
+                </c:pt>
+                <c:pt idx="3">
+                  <c:v>0.0156</c:v>
+                </c:pt>
+              </c:numCache>
+            </c:numRef>
+          </c:val>
+        </c:ser>
+        <c:axId val="-2068027336"/>
+        <c:axId val="-2113994440"/>
+      </c:barChart>
+      <c:catAx>
+        <c:axId val="-2068027336"/>
+        <c:scaling>
+          <c:orientation val="minMax"/>
+        </c:scaling>
+        <c:delete val="0"/>
+        <c:axPos val="b"/>
+        <c:majorTickMark val="out"/>
+        <c:minorTickMark val="none"/>
+        <c:tickLblPos val="nextTo"/>
+        <c:txPr>
+          <a:bodyPr/>
+          <a:lstStyle/>
+          <a:p>
+            <a:pPr>
+              <a:defRPr sz="1100">
+                <a:solidFill>
+                  <a:srgbClr val="9CA3AF"/>
+                </a:solidFill>
+              </a:defRPr>
+            </a:pPr>
+          </a:p>
+        </c:txPr>
+        <c:crossAx val="-2113994440"/>
+        <c:crosses val="autoZero"/>
+        <c:auto val="1"/>
+        <c:lblAlgn val="ctr"/>
+        <c:lblOffset val="100"/>
+        <c:noMultiLvlLbl val="0"/>
+      </c:catAx>
+      <c:valAx>
+        <c:axId val="-2113994440"/>
+        <c:scaling>
+          <c:max val="1.0"/>
+        </c:scaling>
+        <c:delete val="0"/>
+        <c:axPos val="l"/>
+        <c:majorGridlines>
+          <c:spPr>
+            <a:ln>
+              <a:solidFill>
+                <a:srgbClr val="2A2D3A"/>
+              </a:solidFill>
+            </a:ln>
+          </c:spPr>
+        </c:majorGridlines>
+        <c:majorTickMark val="out"/>
+        <c:minorTickMark val="none"/>
+        <c:tickLblPos val="nextTo"/>
+        <c:txPr>
+          <a:bodyPr/>
+          <a:lstStyle/>
+          <a:p>
+            <a:pPr>
+              <a:defRPr sz="1100">
+                <a:solidFill>
+                  <a:srgbClr val="9CA3AF"/>
+                </a:solidFill>
+              </a:defRPr>
+            </a:pPr>
+          </a:p>
+        </c:txPr>
+        <c:crossAx val="-2068027336"/>
+        <c:crosses val="autoZero"/>
+      </c:valAx>
+    </c:plotArea>
+    <c:legend>
+      <c:legendPos val="b"/>
+      <c:overlay val="0"/>
+      <c:txPr>
+        <a:bodyPr/>
+        <a:lstStyle/>
+        <a:p>
+          <a:pPr>
+            <a:defRPr>
+              <a:solidFill>
+                <a:srgbClr val="E5E7EB"/>
+              </a:solidFill>
+            </a:defRPr>
+          </a:pPr>
+        </a:p>
+      </c:txPr>
+    </c:legend>
+    <c:dispBlanksAs val="gap"/>
   </c:chart>
   <c:txPr>
     <a:bodyPr/>
@@ -3957,7 +4273,7 @@
                 </a:solidFill>
                 <a:latin typeface="Calibri"/>
               </a:rPr>
-              <a:t>Enseñar lo cuántico</a:t>
+              <a:t>La probabilidad cuántica no se intuye</a:t>
             </a:r>
           </a:p>
         </p:txBody>
@@ -3996,7 +4312,7 @@
                 </a:solidFill>
                 <a:latin typeface="Calibri"/>
               </a:rPr>
-              <a:t>Se explica como magia o como fórmulas sin intuición.</a:t>
+              <a:t>Las amplitudes pueden ser negativas y cancelarse; la estadística escolar no lo anticipa.</a:t>
             </a:r>
           </a:p>
           <a:p>
@@ -4096,7 +4412,7 @@
                 </a:solidFill>
                 <a:latin typeface="Calibri"/>
               </a:rPr>
-              <a:t>Una amenaza real</a:t>
+              <a:t>Una amenaza mal contada</a:t>
             </a:r>
           </a:p>
         </p:txBody>
@@ -4135,7 +4451,7 @@
                 </a:solidFill>
                 <a:latin typeface="Calibri"/>
               </a:rPr>
-              <a:t>Datos cifrados hoy pueden guardarse y descifrarse mañana (harvest now, decrypt later).</a:t>
+              <a:t>Se dice «romperá todas las contraseñas». Grover solo da mejora cuadrática; el riesgo real es Shor contra RSA/ECC y los datos que se guardan hoy (harvest now, decrypt later).</a:t>
             </a:r>
           </a:p>
         </p:txBody>
@@ -4275,6 +4591,22 @@
                 <a:latin typeface="Calibri"/>
               </a:rPr>
               <a:t>Grover lo encuentra con 3 iteraciones. ¿Cómo se siente esa diferencia?</a:t>
+            </a:r>
+          </a:p>
+          <a:p>
+            <a:pPr>
+              <a:spcAft>
+                <a:spcPts val="600"/>
+              </a:spcAft>
+            </a:pPr>
+            <a:r>
+              <a:rPr sz="1600" b="0">
+                <a:solidFill>
+                  <a:srgbClr val="E5E7EB"/>
+                </a:solidFill>
+                <a:latin typeface="Calibri"/>
+              </a:rPr>
+              <a:t>Para quién: desde 14 años, unos 3 minutos al día, sin cuenta IBM ni instalar nada.</a:t>
             </a:r>
           </a:p>
         </p:txBody>
@@ -4825,61 +5157,61 @@
               </a:spcAft>
             </a:pPr>
             <a:r>
-              <a:rPr sz="2000" b="0">
+              <a:rPr sz="1800" b="0">
                 <a:solidFill>
                   <a:srgbClr val="E5E7EB"/>
                 </a:solidFill>
                 <a:latin typeface="Consolas"/>
               </a:rPr>
-              <a:t>Ejemplo n=4 (N=16)</a:t>
-            </a:r>
-          </a:p>
-          <a:p>
-            <a:pPr>
-              <a:spcAft>
-                <a:spcPts val="600"/>
-              </a:spcAft>
-            </a:pPr>
-            <a:r>
-              <a:rPr sz="2000" b="0">
+              <a:t>Ejemplo n=4 (N=16): clásico 8,5 intentos; Grover k=3, P teórica ≈ 96,1 %</a:t>
+            </a:r>
+          </a:p>
+          <a:p>
+            <a:pPr>
+              <a:spcAft>
+                <a:spcPts val="600"/>
+              </a:spcAft>
+            </a:pPr>
+            <a:r>
+              <a:rPr sz="1800" b="0">
                 <a:solidFill>
                   <a:srgbClr val="E5E7EB"/>
                 </a:solidFill>
                 <a:latin typeface="Consolas"/>
               </a:rPr>
-              <a:t>Clásico: 8,5 intentos esperados</a:t>
-            </a:r>
-          </a:p>
-          <a:p>
-            <a:pPr>
-              <a:spcAft>
-                <a:spcPts val="600"/>
-              </a:spcAft>
-            </a:pPr>
-            <a:r>
-              <a:rPr sz="2000" b="0">
+              <a:t>Mejora cuadrática, no exponencial.</a:t>
+            </a:r>
+          </a:p>
+          <a:p>
+            <a:pPr>
+              <a:spcAft>
+                <a:spcPts val="600"/>
+              </a:spcAft>
+            </a:pPr>
+            <a:r>
+              <a:rPr sz="1800" b="0">
                 <a:solidFill>
                   <a:srgbClr val="E5E7EB"/>
                 </a:solidFill>
                 <a:latin typeface="Consolas"/>
               </a:rPr>
-              <a:t>Grover: k=3 iteraciones, P teórica ≈ 96,1 %</a:t>
-            </a:r>
-          </a:p>
-          <a:p>
-            <a:pPr>
-              <a:spcAft>
-                <a:spcPts val="600"/>
-              </a:spcAft>
-            </a:pPr>
-            <a:r>
-              <a:rPr sz="2000" b="0">
+              <a:t>Eje del reto: distribuciones de probabilidad → superposición y amplitudes.</a:t>
+            </a:r>
+          </a:p>
+          <a:p>
+            <a:pPr>
+              <a:spcAft>
+                <a:spcPts val="600"/>
+              </a:spcAft>
+            </a:pPr>
+            <a:r>
+              <a:rPr sz="1800" b="0">
                 <a:solidFill>
                   <a:srgbClr val="E5E7EB"/>
                 </a:solidFill>
                 <a:latin typeface="Consolas"/>
               </a:rPr>
-              <a:t>Mejora cuadrática, no exponencial.</a:t>
+              <a:t>Monte Carlo es aquí la referencia clásica: NO implementamos QAE.</a:t>
             </a:r>
           </a:p>
         </p:txBody>
@@ -5181,7 +5513,23 @@
                 </a:solidFill>
                 <a:latin typeface="Calibri"/>
               </a:rPr>
-              <a:t>Contraseñas solo aquí</a:t>
+              <a:t>Explorador y contraseñas</a:t>
+            </a:r>
+          </a:p>
+          <a:p>
+            <a:pPr>
+              <a:spcAft>
+                <a:spcPts val="600"/>
+              </a:spcAft>
+            </a:pPr>
+            <a:r>
+              <a:rPr sz="1600" b="0">
+                <a:solidFill>
+                  <a:srgbClr val="E5E7EB"/>
+                </a:solidFill>
+                <a:latin typeface="Calibri"/>
+              </a:rPr>
+              <a:t>solo en el navegador</a:t>
             </a:r>
           </a:p>
         </p:txBody>
@@ -5610,7 +5958,7 @@
               </a:spcAft>
             </a:pPr>
             <a:r>
-              <a:rPr sz="1800" b="0">
+              <a:rPr sz="1700" b="0">
                 <a:solidFill>
                   <a:srgbClr val="E5E7EB"/>
                 </a:solidFill>
@@ -5626,23 +5974,23 @@
               </a:spcAft>
             </a:pPr>
             <a:r>
-              <a:rPr sz="1800" b="0">
+              <a:rPr sz="1700" b="0">
                 <a:solidFill>
                   <a:srgbClr val="E5E7EB"/>
                 </a:solidFill>
                 <a:latin typeface="Consolas"/>
               </a:rPr>
-              <a:t>histograma + curva sin² exacta + circuito + ruido FakeFez</a:t>
-            </a:r>
-          </a:p>
-          <a:p>
-            <a:pPr>
-              <a:spcAft>
-                <a:spcPts val="600"/>
-              </a:spcAft>
-            </a:pPr>
-            <a:r>
-              <a:rPr sz="1800" b="0">
+              <a:t>Explorador de amplitudes en vivo (fórmulas exactas, sin servidor)</a:t>
+            </a:r>
+          </a:p>
+          <a:p>
+            <a:pPr>
+              <a:spcAft>
+                <a:spcPts val="600"/>
+              </a:spcAft>
+            </a:pPr>
+            <a:r>
+              <a:rPr sz="1700" b="0">
                 <a:solidFill>
                   <a:srgbClr val="E5E7EB"/>
                 </a:solidFill>
@@ -5658,13 +6006,29 @@
               </a:spcAft>
             </a:pPr>
             <a:r>
-              <a:rPr sz="1800" b="0">
+              <a:rPr sz="1700" b="0">
                 <a:solidFill>
                   <a:srgbClr val="E5E7EB"/>
                 </a:solidFill>
                 <a:latin typeface="Consolas"/>
               </a:rPr>
-              <a:t>Calidad: 42 pruebas pytest, 23 de frontend, WCAG 2.2 AA</a:t>
+              <a:t>CLI scripts/run_ibm_hardware.py: fake | dry-run | ibm | --job-id</a:t>
+            </a:r>
+          </a:p>
+          <a:p>
+            <a:pPr>
+              <a:spcAft>
+                <a:spcPts val="600"/>
+              </a:spcAft>
+            </a:pPr>
+            <a:r>
+              <a:rPr sz="1700" b="0">
+                <a:solidFill>
+                  <a:srgbClr val="E5E7EB"/>
+                </a:solidFill>
+                <a:latin typeface="Consolas"/>
+              </a:rPr>
+              <a:t>Calidad: 67 pruebas pytest, 36 de frontend, objetivo WCAG 2.2 AA</a:t>
             </a:r>
           </a:p>
         </p:txBody>
@@ -5825,7 +6189,7 @@
         <p:spPr>
           <a:xfrm>
             <a:off x="548640" y="1371600"/>
-            <a:ext cx="4572000" cy="4114800"/>
+            <a:ext cx="4572000" cy="4480560"/>
           </a:xfrm>
           <a:prstGeom prst="rect">
             <a:avLst/>
@@ -5844,23 +6208,23 @@
               </a:spcAft>
             </a:pPr>
             <a:r>
-              <a:rPr sz="1800" b="0">
+              <a:rPr sz="1600" b="0">
                 <a:solidFill>
                   <a:srgbClr val="E5E7EB"/>
                 </a:solidFill>
                 <a:latin typeface="Calibri"/>
               </a:rPr>
-              <a:t>Qiskit 2.6: circuitos oráculo + difusor</a:t>
-            </a:r>
-          </a:p>
-          <a:p>
-            <a:pPr>
-              <a:spcAft>
-                <a:spcPts val="600"/>
-              </a:spcAft>
-            </a:pPr>
-            <a:r>
-              <a:rPr sz="1800" b="0">
+              <a:t>Qiskit 2.6: circuitos oráculo + difusor, que se ejecutan</a:t>
+            </a:r>
+          </a:p>
+          <a:p>
+            <a:pPr>
+              <a:spcAft>
+                <a:spcPts val="600"/>
+              </a:spcAft>
+            </a:pPr>
+            <a:r>
+              <a:rPr sz="1600" b="0">
                 <a:solidFill>
                   <a:srgbClr val="E5E7EB"/>
                 </a:solidFill>
@@ -5876,7 +6240,7 @@
               </a:spcAft>
             </a:pPr>
             <a:r>
-              <a:rPr sz="1800" b="0">
+              <a:rPr sz="1600" b="0">
                 <a:solidFill>
                   <a:srgbClr val="E5E7EB"/>
                 </a:solidFill>
@@ -5892,7 +6256,7 @@
               </a:spcAft>
             </a:pPr>
             <a:r>
-              <a:rPr sz="1800" b="0">
+              <a:rPr sz="1600" b="0">
                 <a:solidFill>
                   <a:srgbClr val="E5E7EB"/>
                 </a:solidFill>
@@ -5908,13 +6272,29 @@
               </a:spcAft>
             </a:pPr>
             <a:r>
-              <a:rPr sz="1800" b="0">
+              <a:rPr sz="1600" b="0">
                 <a:solidFill>
                   <a:srgbClr val="E5E7EB"/>
                 </a:solidFill>
                 <a:latin typeface="Calibri"/>
               </a:rPr>
-              <a:t>qiskit-ibm-runtime: listo para hardware</a:t>
+              <a:t>transpile: profundidad y puertas de 2 qubits</a:t>
+            </a:r>
+          </a:p>
+          <a:p>
+            <a:pPr>
+              <a:spcAft>
+                <a:spcPts val="600"/>
+              </a:spcAft>
+            </a:pPr>
+            <a:r>
+              <a:rPr sz="1600" b="0">
+                <a:solidFill>
+                  <a:srgbClr val="E5E7EB"/>
+                </a:solidFill>
+                <a:latin typeface="Calibri"/>
+              </a:rPr>
+              <a:t>qiskit-ibm-runtime: CLI listo para hardware, aún sin ejecutar</a:t>
             </a:r>
           </a:p>
         </p:txBody>
@@ -5997,7 +6377,7 @@
                 </a:solidFill>
                 <a:latin typeface="Calibri"/>
               </a:rPr>
-              <a:t>Seguridad, generador y poscuántica</a:t>
+              <a:t>El ruido borra la amplificación</a:t>
             </a:r>
           </a:p>
         </p:txBody>
@@ -6086,59 +6466,14 @@
       </p:sp>
       <p:sp>
         <p:nvSpPr>
-          <p:cNvPr id="5" name="Rectangle 4"/>
-          <p:cNvSpPr/>
-          <p:nvPr/>
-        </p:nvSpPr>
-        <p:spPr>
-          <a:xfrm>
-            <a:off x="548640" y="1463040"/>
-            <a:ext cx="5394960" cy="4389120"/>
-          </a:xfrm>
-          <a:prstGeom prst="rect">
-            <a:avLst/>
-          </a:prstGeom>
-          <a:solidFill>
-            <a:srgbClr val="141622"/>
-          </a:solidFill>
-          <a:ln w="19050">
-            <a:solidFill>
-              <a:srgbClr val="22D3EE"/>
-            </a:solidFill>
-          </a:ln>
-        </p:spPr>
-        <p:style>
-          <a:lnRef idx="1">
-            <a:schemeClr val="accent1"/>
-          </a:lnRef>
-          <a:fillRef idx="3">
-            <a:schemeClr val="accent1"/>
-          </a:fillRef>
-          <a:effectRef idx="2">
-            <a:schemeClr val="accent1"/>
-          </a:effectRef>
-          <a:fontRef idx="minor">
-            <a:schemeClr val="lt1"/>
-          </a:fontRef>
-        </p:style>
-        <p:txBody>
-          <a:bodyPr rtlCol="0" anchor="ctr"/>
-          <a:lstStyle/>
-          <a:p>
-            <a:pPr algn="ctr"/>
-          </a:p>
-        </p:txBody>
-      </p:sp>
-      <p:sp>
-        <p:nvSpPr>
-          <p:cNvPr id="6" name="TextBox 5"/>
+          <p:cNvPr id="5" name="TextBox 4"/>
           <p:cNvSpPr txBox="1"/>
           <p:nvPr/>
         </p:nvSpPr>
         <p:spPr>
           <a:xfrm>
-            <a:off x="731520" y="1554480"/>
-            <a:ext cx="5029200" cy="457200"/>
+            <a:off x="548640" y="1371600"/>
+            <a:ext cx="4572000" cy="4754880"/>
           </a:xfrm>
           <a:prstGeom prst="rect">
             <a:avLst/>
@@ -6157,275 +6492,99 @@
               </a:spcAft>
             </a:pPr>
             <a:r>
-              <a:rPr sz="2000" b="1">
-                <a:solidFill>
-                  <a:srgbClr val="22D3EE"/>
+              <a:rPr sz="1600" b="0">
+                <a:solidFill>
+                  <a:srgbClr val="E5E7EB"/>
                 </a:solidFill>
                 <a:latin typeface="Calibri"/>
               </a:rPr>
-              <a:t>Generador en el navegador</a:t>
-            </a:r>
-          </a:p>
-        </p:txBody>
-      </p:sp>
-      <p:sp>
-        <p:nvSpPr>
-          <p:cNvPr id="7" name="TextBox 6"/>
-          <p:cNvSpPr txBox="1"/>
+              <a:t>Mismo circuito del laboratorio, medido con el CLI en FakeFez (seed 7, 1024 disparos).</a:t>
+            </a:r>
+          </a:p>
+          <a:p>
+            <a:pPr>
+              <a:spcAft>
+                <a:spcPts val="600"/>
+              </a:spcAft>
+            </a:pPr>
+            <a:r>
+              <a:rPr sz="1600" b="0">
+                <a:solidFill>
+                  <a:srgbClr val="E5E7EB"/>
+                </a:solidFill>
+                <a:latin typeface="Calibri"/>
+              </a:rPr>
+              <a:t>n=3: profundidad 137, 39 puertas de 2 qubits, éxito 0,802.</a:t>
+            </a:r>
+          </a:p>
+          <a:p>
+            <a:pPr>
+              <a:spcAft>
+                <a:spcPts val="600"/>
+              </a:spcAft>
+            </a:pPr>
+            <a:r>
+              <a:rPr sz="1600" b="0">
+                <a:solidFill>
+                  <a:srgbClr val="E5E7EB"/>
+                </a:solidFill>
+                <a:latin typeface="Calibri"/>
+              </a:rPr>
+              <a:t>n=6: profundidad 4447, 1706 puertas, éxito 0,0166, igual que el azar (0,0156).</a:t>
+            </a:r>
+          </a:p>
+          <a:p>
+            <a:pPr>
+              <a:spcAft>
+                <a:spcPts val="600"/>
+              </a:spcAft>
+            </a:pPr>
+            <a:r>
+              <a:rPr sz="1600" b="0">
+                <a:solidFill>
+                  <a:srgbClr val="E5E7EB"/>
+                </a:solidFill>
+                <a:latin typeface="Calibri"/>
+              </a:rPr>
+              <a:t>Al crecer el circuito, el ruido NISQ borra la ventaja.</a:t>
+            </a:r>
+          </a:p>
+          <a:p>
+            <a:pPr>
+              <a:spcAft>
+                <a:spcPts val="600"/>
+              </a:spcAft>
+            </a:pPr>
+            <a:r>
+              <a:rPr sz="1600" b="0">
+                <a:solidFill>
+                  <a:srgbClr val="E5E7EB"/>
+                </a:solidFill>
+                <a:latin typeface="Calibri"/>
+              </a:rPr>
+              <a:t>Simulación: NO se ejecutó en hardware real. El CLI (dry-run / ibm) está listo; falta una cuenta.</a:t>
+            </a:r>
+          </a:p>
+        </p:txBody>
+      </p:sp>
+      <p:graphicFrame>
+        <p:nvGraphicFramePr>
+          <p:cNvPr id="6" name="Chart 5"/>
+          <p:cNvGraphicFramePr>
+            <a:graphicFrameLocks noGrp="1"/>
+          </p:cNvGraphicFramePr>
           <p:nvPr/>
-        </p:nvSpPr>
-        <p:spPr>
-          <a:xfrm>
-            <a:off x="731520" y="2057400"/>
-            <a:ext cx="5029200" cy="3749039"/>
-          </a:xfrm>
-          <a:prstGeom prst="rect">
-            <a:avLst/>
-          </a:prstGeom>
-          <a:noFill/>
-        </p:spPr>
-        <p:txBody>
-          <a:bodyPr wrap="square">
-            <a:spAutoFit/>
-          </a:bodyPr>
-          <a:lstStyle/>
-          <a:p>
-            <a:pPr>
-              <a:spcAft>
-                <a:spcPts val="600"/>
-              </a:spcAft>
-            </a:pPr>
-            <a:r>
-              <a:rPr sz="1600" b="0">
-                <a:solidFill>
-                  <a:srgbClr val="E5E7EB"/>
-                </a:solidFill>
-                <a:latin typeface="Calibri"/>
-              </a:rPr>
-              <a:t>crypto.getRandomValues, sin semilla: el código es público y aun así no se puede reproducir.</a:t>
-            </a:r>
-          </a:p>
-          <a:p>
-            <a:pPr>
-              <a:spcAft>
-                <a:spcPts val="600"/>
-              </a:spcAft>
-            </a:pPr>
-            <a:r>
-              <a:rPr sz="1600" b="0">
-                <a:solidFill>
-                  <a:srgbClr val="E5E7EB"/>
-                </a:solidFill>
-                <a:latin typeface="Calibri"/>
-              </a:rPr>
-              <a:t>Caracteres, frase (2072 palabras) o mejorar la mía.</a:t>
-            </a:r>
-          </a:p>
-          <a:p>
-            <a:pPr>
-              <a:spcAft>
-                <a:spcPts val="600"/>
-              </a:spcAft>
-            </a:pPr>
-            <a:r>
-              <a:rPr sz="1600" b="0">
-                <a:solidFill>
-                  <a:srgbClr val="E5E7EB"/>
-                </a:solidFill>
-                <a:latin typeface="Calibri"/>
-              </a:rPr>
-              <a:t>Meta resistente a Grover: 128 bits (64 efectivos).</a:t>
-            </a:r>
-          </a:p>
-          <a:p>
-            <a:pPr>
-              <a:spcAft>
-                <a:spcPts val="600"/>
-              </a:spcAft>
-            </a:pPr>
-            <a:r>
-              <a:rPr sz="1600" b="0">
-                <a:solidFill>
-                  <a:srgbClr val="E5E7EB"/>
-                </a:solidFill>
-                <a:latin typeface="Calibri"/>
-              </a:rPr>
-              <a:t>La contraseña nunca va al backend; un test lo comprueba.</a:t>
-            </a:r>
-          </a:p>
-        </p:txBody>
-      </p:sp>
-      <p:sp>
-        <p:nvSpPr>
-          <p:cNvPr id="8" name="Rectangle 7"/>
-          <p:cNvSpPr/>
-          <p:nvPr/>
-        </p:nvSpPr>
-        <p:spPr>
-          <a:xfrm>
-            <a:off x="6217920" y="1463040"/>
-            <a:ext cx="5394960" cy="4389120"/>
-          </a:xfrm>
-          <a:prstGeom prst="rect">
-            <a:avLst/>
-          </a:prstGeom>
-          <a:solidFill>
-            <a:srgbClr val="141622"/>
-          </a:solidFill>
-          <a:ln w="19050">
-            <a:solidFill>
-              <a:srgbClr val="E879F9"/>
-            </a:solidFill>
-          </a:ln>
-        </p:spPr>
-        <p:style>
-          <a:lnRef idx="1">
-            <a:schemeClr val="accent1"/>
-          </a:lnRef>
-          <a:fillRef idx="3">
-            <a:schemeClr val="accent1"/>
-          </a:fillRef>
-          <a:effectRef idx="2">
-            <a:schemeClr val="accent1"/>
-          </a:effectRef>
-          <a:fontRef idx="minor">
-            <a:schemeClr val="lt1"/>
-          </a:fontRef>
-        </p:style>
-        <p:txBody>
-          <a:bodyPr rtlCol="0" anchor="ctr"/>
-          <a:lstStyle/>
-          <a:p>
-            <a:pPr algn="ctr"/>
-          </a:p>
-        </p:txBody>
-      </p:sp>
-      <p:sp>
-        <p:nvSpPr>
-          <p:cNvPr id="9" name="TextBox 8"/>
-          <p:cNvSpPr txBox="1"/>
-          <p:nvPr/>
-        </p:nvSpPr>
-        <p:spPr>
-          <a:xfrm>
-            <a:off x="6400800" y="1554480"/>
-            <a:ext cx="5029200" cy="457200"/>
-          </a:xfrm>
-          <a:prstGeom prst="rect">
-            <a:avLst/>
-          </a:prstGeom>
-          <a:noFill/>
-        </p:spPr>
-        <p:txBody>
-          <a:bodyPr wrap="square">
-            <a:spAutoFit/>
-          </a:bodyPr>
-          <a:lstStyle/>
-          <a:p>
-            <a:pPr>
-              <a:spcAft>
-                <a:spcPts val="600"/>
-              </a:spcAft>
-            </a:pPr>
-            <a:r>
-              <a:rPr sz="2000" b="1">
-                <a:solidFill>
-                  <a:srgbClr val="E879F9"/>
-                </a:solidFill>
-                <a:latin typeface="Calibri"/>
-              </a:rPr>
-              <a:t>Seguridad y poscuántica</a:t>
-            </a:r>
-          </a:p>
-        </p:txBody>
-      </p:sp>
-      <p:sp>
-        <p:nvSpPr>
-          <p:cNvPr id="10" name="TextBox 9"/>
-          <p:cNvSpPr txBox="1"/>
-          <p:nvPr/>
-        </p:nvSpPr>
-        <p:spPr>
-          <a:xfrm>
-            <a:off x="6400800" y="2057400"/>
-            <a:ext cx="5029200" cy="3749039"/>
-          </a:xfrm>
-          <a:prstGeom prst="rect">
-            <a:avLst/>
-          </a:prstGeom>
-          <a:noFill/>
-        </p:spPr>
-        <p:txBody>
-          <a:bodyPr wrap="square">
-            <a:spAutoFit/>
-          </a:bodyPr>
-          <a:lstStyle/>
-          <a:p>
-            <a:pPr>
-              <a:spcAft>
-                <a:spcPts val="600"/>
-              </a:spcAft>
-            </a:pPr>
-            <a:r>
-              <a:rPr sz="1600" b="0">
-                <a:solidFill>
-                  <a:srgbClr val="E5E7EB"/>
-                </a:solidFill>
-                <a:latin typeface="Calibri"/>
-              </a:rPr>
-              <a:t>CSP default-src 'self', solo archivos públicos, gzip y caché.</a:t>
-            </a:r>
-          </a:p>
-          <a:p>
-            <a:pPr>
-              <a:spcAft>
-                <a:spcPts val="600"/>
-              </a:spcAft>
-            </a:pPr>
-            <a:r>
-              <a:rPr sz="1600" b="0">
-                <a:solidFill>
-                  <a:srgbClr val="E5E7EB"/>
-                </a:solidFill>
-                <a:latin typeface="Calibri"/>
-              </a:rPr>
-              <a:t>Máximo 2 simulaciones ruidosas a la vez (503 + Retry-After).</a:t>
-            </a:r>
-          </a:p>
-          <a:p>
-            <a:pPr>
-              <a:spcAft>
-                <a:spcPts val="600"/>
-              </a:spcAft>
-            </a:pPr>
-            <a:r>
-              <a:rPr sz="1600" b="0">
-                <a:solidFill>
-                  <a:srgbClr val="E5E7EB"/>
-                </a:solidFill>
-                <a:latin typeface="Calibri"/>
-              </a:rPr>
-              <a:t>Funciona sin internet; demo con Cloudflare Tunnel.</a:t>
-            </a:r>
-          </a:p>
-          <a:p>
-            <a:pPr>
-              <a:spcAft>
-                <a:spcPts val="600"/>
-              </a:spcAft>
-            </a:pPr>
-            <a:r>
-              <a:rPr sz="1600" b="0">
-                <a:solidFill>
-                  <a:srgbClr val="E5E7EB"/>
-                </a:solidFill>
-                <a:latin typeface="Calibri"/>
-              </a:rPr>
-              <a:t>Grover vs AES: claves más largas. Shor vs RSA/ECC: migrar a NIST FIPS 203 / 204 / 205.</a:t>
-            </a:r>
-          </a:p>
-        </p:txBody>
-      </p:sp>
+        </p:nvGraphicFramePr>
+        <p:xfrm>
+          <a:off x="5303520" y="1371600"/>
+          <a:ext cx="6492240" cy="4754880"/>
+        </p:xfrm>
+        <a:graphic>
+          <a:graphicData uri="http://schemas.openxmlformats.org/drawingml/2006/chart">
+            <c:chart xmlns:c="http://schemas.openxmlformats.org/drawingml/2006/chart" r:id="rId2"/>
+          </a:graphicData>
+        </a:graphic>
+      </p:graphicFrame>
     </p:spTree>
   </p:cSld>
   <p:clrMapOvr>
@@ -6707,7 +6866,7 @@
                 </a:solidFill>
                 <a:latin typeface="Consolas"/>
               </a:rPr>
-              <a:t>medido 0,954 vs teórico 0,961</a:t>
+              <a:t>medido 0,953 vs teórico 0,961</a:t>
             </a:r>
           </a:p>
           <a:p>
@@ -6739,7 +6898,7 @@
                 </a:solidFill>
                 <a:latin typeface="Consolas"/>
               </a:rPr>
-              <a:t>FakeFez n=6: éxito 0,031 ≈ azar (1/64)</a:t>
+              <a:t>Monte Carlo 10 bits: media 513,3 vs 512,5</a:t>
             </a:r>
           </a:p>
           <a:p>
@@ -6755,7 +6914,23 @@
                 </a:solidFill>
                 <a:latin typeface="Consolas"/>
               </a:rPr>
-              <a:t>Monte Carlo 10 bits: media 513,3 vs 512,5</a:t>
+              <a:t>FakeFez (CLI): 0,802 con n=3, 0,0166 con n=6</a:t>
+            </a:r>
+          </a:p>
+          <a:p>
+            <a:pPr>
+              <a:spcAft>
+                <a:spcPts val="600"/>
+              </a:spcAft>
+            </a:pPr>
+            <a:r>
+              <a:rPr sz="1600" b="0">
+                <a:solidFill>
+                  <a:srgbClr val="E5E7EB"/>
+                </a:solidFill>
+                <a:latin typeface="Consolas"/>
+              </a:rPr>
+              <a:t>67 pruebas pytest, 36 de frontend</a:t>
             </a:r>
           </a:p>
         </p:txBody>
@@ -6878,7 +7053,7 @@
                 </a:solidFill>
                 <a:latin typeface="Calibri"/>
               </a:rPr>
-              <a:t>Ruido simulado (FakeFez), no hardware real.</a:t>
+              <a:t>Ruido simulado (FakeFez): sin hardware real.</a:t>
             </a:r>
           </a:p>
           <a:p>
@@ -6910,7 +7085,7 @@
                 </a:solidFill>
                 <a:latin typeface="Calibri"/>
               </a:rPr>
-              <a:t>Simulación hasta 6 qubits (crece exponencial).</a:t>
+              <a:t>Simulación hasta 6 qubits; no hay QAE.</a:t>
             </a:r>
           </a:p>
           <a:p>
@@ -6926,7 +7101,7 @@
                 </a:solidFill>
                 <a:latin typeface="Calibri"/>
               </a:rPr>
-              <a:t>El ruido borra la amplificación.</a:t>
+              <a:t>El oráculo ya conoce la respuesta.</a:t>
             </a:r>
           </a:p>
           <a:p>
@@ -6942,7 +7117,7 @@
                 </a:solidFill>
                 <a:latin typeface="Calibri"/>
               </a:rPr>
-              <a:t>Retención en aula: sin medir todavía.</a:t>
+              <a:t>Piloto con usuarios y retención: pendientes.</a:t>
             </a:r>
           </a:p>
         </p:txBody>
@@ -7471,8 +7646,8 @@
         </p:nvSpPr>
         <p:spPr>
           <a:xfrm>
-            <a:off x="548640" y="3840480"/>
-            <a:ext cx="11064240" cy="1280160"/>
+            <a:off x="548640" y="3749039"/>
+            <a:ext cx="11064240" cy="1097280"/>
           </a:xfrm>
           <a:prstGeom prst="rect">
             <a:avLst/>
@@ -7526,7 +7701,46 @@
         </p:nvSpPr>
         <p:spPr>
           <a:xfrm>
-            <a:off x="548640" y="5394960"/>
+            <a:off x="548640" y="4754880"/>
+            <a:ext cx="11064240" cy="640080"/>
+          </a:xfrm>
+          <a:prstGeom prst="rect">
+            <a:avLst/>
+          </a:prstGeom>
+          <a:noFill/>
+        </p:spPr>
+        <p:txBody>
+          <a:bodyPr wrap="square">
+            <a:spAutoFit/>
+          </a:bodyPr>
+          <a:lstStyle/>
+          <a:p>
+            <a:pPr>
+              <a:spcAft>
+                <a:spcPts val="600"/>
+              </a:spcAft>
+            </a:pPr>
+            <a:r>
+              <a:rPr sz="1600" b="0">
+                <a:solidFill>
+                  <a:srgbClr val="9CA3AF"/>
+                </a:solidFill>
+                <a:latin typeface="Calibri"/>
+              </a:rPr>
+              <a:t>Explorador de amplitudes en vivo y generador de contraseñas local (CSPRNG, sin semilla): 128 bits = 64 efectivos frente a Grover.</a:t>
+            </a:r>
+          </a:p>
+        </p:txBody>
+      </p:sp>
+      <p:sp>
+        <p:nvSpPr>
+          <p:cNvPr id="16" name="TextBox 15"/>
+          <p:cNvSpPr txBox="1"/>
+          <p:nvPr/>
+        </p:nvSpPr>
+        <p:spPr>
+          <a:xfrm>
+            <a:off x="548640" y="5486400"/>
             <a:ext cx="11064240" cy="822960"/>
           </a:xfrm>
           <a:prstGeom prst="rect">

</xml_diff>

<commit_message>
docs: presentación detallada de 16 slides con capturas, guion para 4 expositores, guía de estudio y skill de diseño para la hackathon
- pitch/QubitGuard_presentacion.pptx (build_presentacion.py), GUION_EXPOSICION.docx (12:20 y versión corta 2:43), GUIA_DE_ESTUDIO.docx (40 páginas).
- skills/qiskit-edtech-hackathon/SKILL.md y BASE_DE_DISENO.txt.
- Capturas reales en pitch/capturas/.
- Arreglos: texto solapado en Evidencia, erratas del contenido de limitaciones y PQC, conteos de pruebas 72/37.
</commit_message>
<xml_diff>
--- a/pitch/QubitGuard_pitch.pptx
+++ b/pitch/QubitGuard_pitch.pptx
@@ -6028,7 +6028,7 @@
                 </a:solidFill>
                 <a:latin typeface="Consolas"/>
               </a:rPr>
-              <a:t>Calidad: 67 pruebas pytest, 36 de frontend, objetivo WCAG 2.2 AA</a:t>
+              <a:t>Calidad: 72 pruebas pytest, 37 de frontend, objetivo WCAG 2.2 AA</a:t>
             </a:r>
           </a:p>
         </p:txBody>
@@ -6930,7 +6930,7 @@
                 </a:solidFill>
                 <a:latin typeface="Consolas"/>
               </a:rPr>
-              <a:t>67 pruebas pytest, 36 de frontend</a:t>
+              <a:t>72 pruebas pytest, 37 de frontend</a:t>
             </a:r>
           </a:p>
         </p:txBody>

</xml_diff>